<commit_message>
feat: add presentation revision summary for BlockVote DApp
</commit_message>
<xml_diff>
--- a/BlockVote_Presentation.pptx
+++ b/BlockVote_Presentation.pptx
@@ -3105,59 +3105,14 @@
       <p:grpSpPr/>
       <p:sp>
         <p:nvSpPr>
-          <p:cNvPr id="2" name="Rectangle 1"/>
-          <p:cNvSpPr/>
-          <p:nvPr/>
-        </p:nvSpPr>
-        <p:spPr>
-          <a:xfrm>
-            <a:off x="0" y="0"/>
-            <a:ext cx="9144000" cy="5143500"/>
-          </a:xfrm>
-          <a:prstGeom prst="rect">
-            <a:avLst/>
-          </a:prstGeom>
-          <a:solidFill>
-            <a:srgbClr val="0F1117"/>
-          </a:solidFill>
-          <a:ln w="38100">
-            <a:solidFill>
-              <a:srgbClr val="7C5CFC"/>
-            </a:solidFill>
-          </a:ln>
-        </p:spPr>
-        <p:style>
-          <a:lnRef idx="1">
-            <a:schemeClr val="accent1"/>
-          </a:lnRef>
-          <a:fillRef idx="3">
-            <a:schemeClr val="accent1"/>
-          </a:fillRef>
-          <a:effectRef idx="2">
-            <a:schemeClr val="accent1"/>
-          </a:effectRef>
-          <a:fontRef idx="minor">
-            <a:schemeClr val="lt1"/>
-          </a:fontRef>
-        </p:style>
-        <p:txBody>
-          <a:bodyPr rtlCol="0" anchor="ctr"/>
-          <a:lstStyle/>
-          <a:p>
-            <a:pPr algn="ctr"/>
-          </a:p>
-        </p:txBody>
-      </p:sp>
-      <p:sp>
-        <p:nvSpPr>
-          <p:cNvPr id="3" name="TextBox 2"/>
+          <p:cNvPr id="2" name="TextBox 1"/>
           <p:cNvSpPr txBox="1"/>
           <p:nvPr/>
         </p:nvSpPr>
         <p:spPr>
           <a:xfrm>
-            <a:off x="457200" y="1371600"/>
-            <a:ext cx="8229600" cy="1371600"/>
+            <a:off x="457200" y="731520"/>
+            <a:ext cx="8229600" cy="548640"/>
           </a:xfrm>
           <a:prstGeom prst="rect">
             <a:avLst/>
@@ -3165,34 +3120,34 @@
           <a:noFill/>
         </p:spPr>
         <p:txBody>
-          <a:bodyPr wrap="none">
+          <a:bodyPr wrap="square">
             <a:spAutoFit/>
           </a:bodyPr>
           <a:lstStyle/>
           <a:p>
             <a:pPr algn="ctr">
-              <a:defRPr sz="5400" b="1">
+              <a:defRPr sz="4800" b="1">
                 <a:solidFill>
                   <a:srgbClr val="7C5CFC"/>
                 </a:solidFill>
               </a:defRPr>
             </a:pPr>
             <a:r>
-              <a:t>🗳️ BlockVote</a:t>
-            </a:r>
-          </a:p>
-        </p:txBody>
-      </p:sp>
-      <p:sp>
-        <p:nvSpPr>
-          <p:cNvPr id="4" name="TextBox 3"/>
+              <a:t>BlockVote</a:t>
+            </a:r>
+          </a:p>
+        </p:txBody>
+      </p:sp>
+      <p:sp>
+        <p:nvSpPr>
+          <p:cNvPr id="3" name="TextBox 2"/>
           <p:cNvSpPr txBox="1"/>
           <p:nvPr/>
         </p:nvSpPr>
         <p:spPr>
           <a:xfrm>
-            <a:off x="457200" y="2926080"/>
-            <a:ext cx="8229600" cy="1828800"/>
+            <a:off x="457200" y="1371600"/>
+            <a:ext cx="8229600" cy="365760"/>
           </a:xfrm>
           <a:prstGeom prst="rect">
             <a:avLst/>
@@ -3200,80 +3155,195 @@
           <a:noFill/>
         </p:spPr>
         <p:txBody>
+          <a:bodyPr wrap="none">
+            <a:spAutoFit/>
+          </a:bodyPr>
+          <a:lstStyle/>
+          <a:p>
+            <a:pPr algn="ctr">
+              <a:defRPr sz="2200">
+                <a:solidFill>
+                  <a:srgbClr val="79C0FF"/>
+                </a:solidFill>
+              </a:defRPr>
+            </a:pPr>
+            <a:r>
+              <a:t>Decentralized Election DApp</a:t>
+            </a:r>
+          </a:p>
+        </p:txBody>
+      </p:sp>
+      <p:sp>
+        <p:nvSpPr>
+          <p:cNvPr id="4" name="TextBox 3"/>
+          <p:cNvSpPr txBox="1"/>
+          <p:nvPr/>
+        </p:nvSpPr>
+        <p:spPr>
+          <a:xfrm>
+            <a:off x="457200" y="1920240"/>
+            <a:ext cx="8229600" cy="274320"/>
+          </a:xfrm>
+          <a:prstGeom prst="rect">
+            <a:avLst/>
+          </a:prstGeom>
+          <a:noFill/>
+        </p:spPr>
+        <p:txBody>
+          <a:bodyPr wrap="none">
+            <a:spAutoFit/>
+          </a:bodyPr>
+          <a:lstStyle/>
+          <a:p>
+            <a:pPr algn="ctr">
+              <a:defRPr sz="1600">
+                <a:solidFill>
+                  <a:srgbClr val="C9D1D9"/>
+                </a:solidFill>
+              </a:defRPr>
+            </a:pPr>
+            <a:r>
+              <a:t>Submitted by: Shai Shargal</a:t>
+            </a:r>
+          </a:p>
+        </p:txBody>
+      </p:sp>
+      <p:sp>
+        <p:nvSpPr>
+          <p:cNvPr id="5" name="TextBox 4"/>
+          <p:cNvSpPr txBox="1"/>
+          <p:nvPr/>
+        </p:nvSpPr>
+        <p:spPr>
+          <a:xfrm>
+            <a:off x="457200" y="2240280"/>
+            <a:ext cx="8229600" cy="228600"/>
+          </a:xfrm>
+          <a:prstGeom prst="rect">
+            <a:avLst/>
+          </a:prstGeom>
+          <a:noFill/>
+        </p:spPr>
+        <p:txBody>
+          <a:bodyPr wrap="none">
+            <a:spAutoFit/>
+          </a:bodyPr>
+          <a:lstStyle/>
+          <a:p>
+            <a:pPr algn="ctr">
+              <a:defRPr sz="1400">
+                <a:solidFill>
+                  <a:srgbClr val="C9D1D9"/>
+                </a:solidFill>
+              </a:defRPr>
+            </a:pPr>
+            <a:r>
+              <a:t>Student ID: 207437559</a:t>
+            </a:r>
+          </a:p>
+        </p:txBody>
+      </p:sp>
+      <p:sp>
+        <p:nvSpPr>
+          <p:cNvPr id="6" name="TextBox 5"/>
+          <p:cNvSpPr txBox="1"/>
+          <p:nvPr/>
+        </p:nvSpPr>
+        <p:spPr>
+          <a:xfrm>
+            <a:off x="457200" y="2560320"/>
+            <a:ext cx="8229600" cy="228600"/>
+          </a:xfrm>
+          <a:prstGeom prst="rect">
+            <a:avLst/>
+          </a:prstGeom>
+          <a:noFill/>
+        </p:spPr>
+        <p:txBody>
+          <a:bodyPr wrap="none">
+            <a:spAutoFit/>
+          </a:bodyPr>
+          <a:lstStyle/>
+          <a:p>
+            <a:pPr algn="ctr">
+              <a:defRPr sz="1400">
+                <a:solidFill>
+                  <a:srgbClr val="C9D1D9"/>
+                </a:solidFill>
+              </a:defRPr>
+            </a:pPr>
+            <a:r>
+              <a:t>Final Course Project (90 points)</a:t>
+            </a:r>
+          </a:p>
+        </p:txBody>
+      </p:sp>
+      <p:sp>
+        <p:nvSpPr>
+          <p:cNvPr id="7" name="TextBox 6"/>
+          <p:cNvSpPr txBox="1"/>
+          <p:nvPr/>
+        </p:nvSpPr>
+        <p:spPr>
+          <a:xfrm>
+            <a:off x="457200" y="2880360"/>
+            <a:ext cx="8229600" cy="228600"/>
+          </a:xfrm>
+          <a:prstGeom prst="rect">
+            <a:avLst/>
+          </a:prstGeom>
+          <a:noFill/>
+        </p:spPr>
+        <p:txBody>
+          <a:bodyPr wrap="none">
+            <a:spAutoFit/>
+          </a:bodyPr>
+          <a:lstStyle/>
+          <a:p>
+            <a:pPr algn="ctr">
+              <a:defRPr sz="1400">
+                <a:solidFill>
+                  <a:srgbClr val="C9D1D9"/>
+                </a:solidFill>
+              </a:defRPr>
+            </a:pPr>
+            <a:r>
+              <a:t>Ethereum Sepolia Testnet</a:t>
+            </a:r>
+          </a:p>
+        </p:txBody>
+      </p:sp>
+      <p:sp>
+        <p:nvSpPr>
+          <p:cNvPr id="8" name="TextBox 7"/>
+          <p:cNvSpPr txBox="1"/>
+          <p:nvPr/>
+        </p:nvSpPr>
+        <p:spPr>
+          <a:xfrm>
+            <a:off x="457200" y="3337560"/>
+            <a:ext cx="8229600" cy="365760"/>
+          </a:xfrm>
+          <a:prstGeom prst="rect">
+            <a:avLst/>
+          </a:prstGeom>
+          <a:noFill/>
+        </p:spPr>
+        <p:txBody>
           <a:bodyPr wrap="square">
             <a:spAutoFit/>
           </a:bodyPr>
           <a:lstStyle/>
           <a:p>
             <a:pPr algn="ctr">
-              <a:spcAft>
-                <a:spcPts val="800"/>
-              </a:spcAft>
-              <a:defRPr sz="1800">
-                <a:solidFill>
-                  <a:srgbClr val="C9D1D9"/>
-                </a:solidFill>
-              </a:defRPr>
-            </a:pPr>
-            <a:r>
-              <a:t>Decentralized Election DApp</a:t>
-            </a:r>
-          </a:p>
-          <a:p>
-            <a:pPr algn="ctr">
-              <a:spcAft>
-                <a:spcPts val="800"/>
-              </a:spcAft>
-              <a:defRPr sz="1800">
-                <a:solidFill>
-                  <a:srgbClr val="C9D1D9"/>
-                </a:solidFill>
-              </a:defRPr>
-            </a:pPr>
-          </a:p>
-          <a:p>
-            <a:pPr algn="ctr">
-              <a:spcAft>
-                <a:spcPts val="800"/>
-              </a:spcAft>
-              <a:defRPr sz="1800">
-                <a:solidFill>
-                  <a:srgbClr val="C9D1D9"/>
-                </a:solidFill>
-              </a:defRPr>
-            </a:pPr>
-            <a:r>
-              <a:t>Submitted by: Shai Shargal</a:t>
-            </a:r>
-          </a:p>
-          <a:p>
-            <a:pPr algn="ctr">
-              <a:spcAft>
-                <a:spcPts val="800"/>
-              </a:spcAft>
-              <a:defRPr sz="1800">
-                <a:solidFill>
-                  <a:srgbClr val="C9D1D9"/>
-                </a:solidFill>
-              </a:defRPr>
-            </a:pPr>
-            <a:r>
-              <a:t>Final Course Project (90 points)</a:t>
-            </a:r>
-          </a:p>
-          <a:p>
-            <a:pPr algn="ctr">
-              <a:spcAft>
-                <a:spcPts val="800"/>
-              </a:spcAft>
-              <a:defRPr sz="1800">
-                <a:solidFill>
-                  <a:srgbClr val="C9D1D9"/>
-                </a:solidFill>
-              </a:defRPr>
-            </a:pPr>
-            <a:r>
-              <a:t>Ethereum Sepolia Deployment</a:t>
+              <a:defRPr sz="1100">
+                <a:solidFill>
+                  <a:srgbClr val="79C0FF"/>
+                </a:solidFill>
+              </a:defRPr>
+            </a:pPr>
+            <a:r>
+              <a:t>github.com/Shai-Shargal/blockchain-election-dapp</a:t>
             </a:r>
           </a:p>
         </p:txBody>
@@ -3313,7 +3383,7 @@
         <p:spPr>
           <a:xfrm>
             <a:off x="457200" y="274320"/>
-            <a:ext cx="8229600" cy="731520"/>
+            <a:ext cx="8229600" cy="548640"/>
           </a:xfrm>
           <a:prstGeom prst="rect">
             <a:avLst/>
@@ -3321,13 +3391,13 @@
           <a:noFill/>
         </p:spPr>
         <p:txBody>
-          <a:bodyPr wrap="none">
+          <a:bodyPr wrap="square">
             <a:spAutoFit/>
           </a:bodyPr>
           <a:lstStyle/>
           <a:p>
             <a:pPr>
-              <a:defRPr sz="3800" b="1">
+              <a:defRPr sz="3600" b="1">
                 <a:solidFill>
                   <a:srgbClr val="7C5CFC"/>
                 </a:solidFill>
@@ -3347,8 +3417,8 @@
         </p:nvSpPr>
         <p:spPr>
           <a:xfrm>
-            <a:off x="457200" y="1051560"/>
-            <a:ext cx="8229600" cy="45720"/>
+            <a:off x="457200" y="960120"/>
+            <a:ext cx="8229600" cy="36576"/>
           </a:xfrm>
           <a:prstGeom prst="rect">
             <a:avLst/>
@@ -3392,8 +3462,8 @@
         </p:nvSpPr>
         <p:spPr>
           <a:xfrm>
-            <a:off x="731520" y="1371600"/>
-            <a:ext cx="7680960" cy="274320"/>
+            <a:off x="731520" y="1234440"/>
+            <a:ext cx="7680960" cy="3474720"/>
           </a:xfrm>
           <a:prstGeom prst="rect">
             <a:avLst/>
@@ -3401,281 +3471,116 @@
           <a:noFill/>
         </p:spPr>
         <p:txBody>
-          <a:bodyPr wrap="none">
+          <a:bodyPr wrap="square" anchor="t">
             <a:spAutoFit/>
           </a:bodyPr>
           <a:lstStyle/>
           <a:p>
             <a:pPr>
-              <a:defRPr sz="1600" b="1">
-                <a:solidFill>
-                  <a:srgbClr val="F87171"/>
-                </a:solidFill>
-              </a:defRPr>
-            </a:pPr>
-            <a:r>
-              <a:t>Known Limitations</a:t>
-            </a:r>
-          </a:p>
-        </p:txBody>
-      </p:sp>
-      <p:sp>
-        <p:nvSpPr>
-          <p:cNvPr id="5" name="TextBox 4"/>
-          <p:cNvSpPr txBox="1"/>
-          <p:nvPr/>
-        </p:nvSpPr>
-        <p:spPr>
-          <a:xfrm>
-            <a:off x="914400" y="1783080"/>
-            <a:ext cx="7680960" cy="1371600"/>
-          </a:xfrm>
-          <a:prstGeom prst="rect">
-            <a:avLst/>
-          </a:prstGeom>
-          <a:noFill/>
-        </p:spPr>
-        <p:txBody>
-          <a:bodyPr wrap="square">
-            <a:spAutoFit/>
-          </a:bodyPr>
-          <a:lstStyle/>
-          <a:p>
-            <a:pPr>
               <a:spcBef>
-                <a:spcPts val="400"/>
+                <a:spcPts val="300"/>
               </a:spcBef>
               <a:spcAft>
-                <a:spcPts val="400"/>
+                <a:spcPts val="300"/>
               </a:spcAft>
-              <a:defRPr sz="1300">
+              <a:defRPr sz="1400">
                 <a:solidFill>
                   <a:srgbClr val="C9D1D9"/>
                 </a:solidFill>
               </a:defRPr>
             </a:pPr>
             <a:r>
-              <a:t>Questionnaire selection is UI-hidden but NOT cryptographically anonymous</a:t>
+              <a:t>• Questionnaire voting is UI-hidden but NOT cryptographically anonymous</a:t>
             </a:r>
           </a:p>
           <a:p>
             <a:pPr>
               <a:spcBef>
-                <a:spcPts val="400"/>
+                <a:spcPts val="300"/>
               </a:spcBef>
               <a:spcAft>
-                <a:spcPts val="400"/>
+                <a:spcPts val="300"/>
               </a:spcAft>
-              <a:defRPr sz="1300">
+              <a:defRPr sz="1400">
                 <a:solidFill>
                   <a:srgbClr val="C9D1D9"/>
                 </a:solidFill>
               </a:defRPr>
             </a:pPr>
             <a:r>
-              <a:t>Candidate ID visible in blockchain transaction calldata (intentional design)</a:t>
+              <a:t>• Candidate ID is visible in blockchain transaction calldata</a:t>
             </a:r>
           </a:p>
           <a:p>
             <a:pPr>
               <a:spcBef>
-                <a:spcPts val="400"/>
+                <a:spcPts val="300"/>
               </a:spcBef>
               <a:spcAft>
-                <a:spcPts val="400"/>
+                <a:spcPts val="300"/>
               </a:spcAft>
-              <a:defRPr sz="1300">
+              <a:defRPr sz="1400">
                 <a:solidFill>
                   <a:srgbClr val="C9D1D9"/>
                 </a:solidFill>
               </a:defRPr>
             </a:pPr>
             <a:r>
-              <a:t>Admin can set election times only once (no modification after configuration)</a:t>
+              <a:t>• Full Sepolia E2E flow still pending manual verification</a:t>
             </a:r>
           </a:p>
           <a:p>
             <a:pPr>
               <a:spcBef>
-                <a:spcPts val="400"/>
+                <a:spcPts val="300"/>
               </a:spcBef>
               <a:spcAft>
-                <a:spcPts val="400"/>
+                <a:spcPts val="300"/>
               </a:spcAft>
-              <a:defRPr sz="1300">
+              <a:defRPr sz="1400">
                 <a:solidFill>
                   <a:srgbClr val="C9D1D9"/>
                 </a:solidFill>
               </a:defRPr>
             </a:pPr>
             <a:r>
-              <a:t>Vote records are permanent (no reversal mechanism)</a:t>
-            </a:r>
-          </a:p>
-        </p:txBody>
-      </p:sp>
-      <p:sp>
-        <p:nvSpPr>
-          <p:cNvPr id="6" name="TextBox 5"/>
-          <p:cNvSpPr txBox="1"/>
-          <p:nvPr/>
-        </p:nvSpPr>
-        <p:spPr>
-          <a:xfrm>
-            <a:off x="731520" y="3337560"/>
-            <a:ext cx="7680960" cy="274320"/>
-          </a:xfrm>
-          <a:prstGeom prst="rect">
-            <a:avLst/>
-          </a:prstGeom>
-          <a:noFill/>
-        </p:spPr>
-        <p:txBody>
-          <a:bodyPr wrap="none">
-            <a:spAutoFit/>
-          </a:bodyPr>
-          <a:lstStyle/>
-          <a:p>
-            <a:pPr>
-              <a:defRPr sz="1600" b="1">
-                <a:solidFill>
-                  <a:srgbClr val="79C0FF"/>
-                </a:solidFill>
-              </a:defRPr>
-            </a:pPr>
-            <a:r>
-              <a:t>✓ Verified Working</a:t>
-            </a:r>
-          </a:p>
-        </p:txBody>
-      </p:sp>
-      <p:sp>
-        <p:nvSpPr>
-          <p:cNvPr id="7" name="TextBox 6"/>
-          <p:cNvSpPr txBox="1"/>
-          <p:nvPr/>
-        </p:nvSpPr>
-        <p:spPr>
-          <a:xfrm>
-            <a:off x="914400" y="3703320"/>
-            <a:ext cx="7680960" cy="1280160"/>
-          </a:xfrm>
-          <a:prstGeom prst="rect">
-            <a:avLst/>
-          </a:prstGeom>
-          <a:noFill/>
-        </p:spPr>
-        <p:txBody>
-          <a:bodyPr wrap="square">
-            <a:spAutoFit/>
-          </a:bodyPr>
-          <a:lstStyle/>
+              <a:t>• IPFS upload and CID storage pending manual verification</a:t>
+            </a:r>
+          </a:p>
           <a:p>
             <a:pPr>
               <a:spcBef>
-                <a:spcPts val="400"/>
+                <a:spcPts val="300"/>
               </a:spcBef>
               <a:spcAft>
-                <a:spcPts val="400"/>
+                <a:spcPts val="300"/>
               </a:spcAft>
-              <a:defRPr sz="1200">
+              <a:defRPr sz="1400">
                 <a:solidFill>
                   <a:srgbClr val="C9D1D9"/>
                 </a:solidFill>
               </a:defRPr>
             </a:pPr>
             <a:r>
-              <a:t>28/28 unit tests passing (Solidity)</a:t>
+              <a:t>• Election times cannot be changed after initial configuration</a:t>
             </a:r>
           </a:p>
           <a:p>
             <a:pPr>
               <a:spcBef>
-                <a:spcPts val="400"/>
+                <a:spcPts val="300"/>
               </a:spcBef>
               <a:spcAft>
-                <a:spcPts val="400"/>
+                <a:spcPts val="300"/>
               </a:spcAft>
-              <a:defRPr sz="1200">
+              <a:defRPr sz="1400">
                 <a:solidFill>
                   <a:srgbClr val="C9D1D9"/>
                 </a:solidFill>
               </a:defRPr>
             </a:pPr>
             <a:r>
-              <a:t>Merkle tree voter verification</a:t>
-            </a:r>
-          </a:p>
-          <a:p>
-            <a:pPr>
-              <a:spcBef>
-                <a:spcPts val="400"/>
-              </a:spcBef>
-              <a:spcAft>
-                <a:spcPts val="400"/>
-              </a:spcAft>
-              <a:defRPr sz="1200">
-                <a:solidFill>
-                  <a:srgbClr val="C9D1D9"/>
-                </a:solidFill>
-              </a:defRPr>
-            </a:pPr>
-            <a:r>
-              <a:t>ERC-20 BAL token minting</a:t>
-            </a:r>
-          </a:p>
-          <a:p>
-            <a:pPr>
-              <a:spcBef>
-                <a:spcPts val="400"/>
-              </a:spcBef>
-              <a:spcAft>
-                <a:spcPts val="400"/>
-              </a:spcAft>
-              <a:defRPr sz="1200">
-                <a:solidFill>
-                  <a:srgbClr val="C9D1D9"/>
-                </a:solidFill>
-              </a:defRPr>
-            </a:pPr>
-            <a:r>
-              <a:t>Admin access control (onlyOwner)</a:t>
-            </a:r>
-          </a:p>
-          <a:p>
-            <a:pPr>
-              <a:spcBef>
-                <a:spcPts val="400"/>
-              </a:spcBef>
-              <a:spcAft>
-                <a:spcPts val="400"/>
-              </a:spcAft>
-              <a:defRPr sz="1200">
-                <a:solidFill>
-                  <a:srgbClr val="C9D1D9"/>
-                </a:solidFill>
-              </a:defRPr>
-            </a:pPr>
-            <a:r>
-              <a:t>Time-gating enforcement</a:t>
-            </a:r>
-          </a:p>
-          <a:p>
-            <a:pPr>
-              <a:spcBef>
-                <a:spcPts val="400"/>
-              </a:spcBef>
-              <a:spcAft>
-                <a:spcPts val="400"/>
-              </a:spcAft>
-              <a:defRPr sz="1200">
-                <a:solidFill>
-                  <a:srgbClr val="C9D1D9"/>
-                </a:solidFill>
-              </a:defRPr>
-            </a:pPr>
-            <a:r>
-              <a:t>Results correctly gated post-election</a:t>
+              <a:t>• Vote records are permanent (no reversal mechanism)</a:t>
             </a:r>
           </a:p>
         </p:txBody>
@@ -3715,7 +3620,7 @@
         <p:spPr>
           <a:xfrm>
             <a:off x="457200" y="274320"/>
-            <a:ext cx="8229600" cy="731520"/>
+            <a:ext cx="8229600" cy="548640"/>
           </a:xfrm>
           <a:prstGeom prst="rect">
             <a:avLst/>
@@ -3723,20 +3628,20 @@
           <a:noFill/>
         </p:spPr>
         <p:txBody>
-          <a:bodyPr wrap="none">
+          <a:bodyPr wrap="square">
             <a:spAutoFit/>
           </a:bodyPr>
           <a:lstStyle/>
           <a:p>
             <a:pPr>
-              <a:defRPr sz="3800" b="1">
+              <a:defRPr sz="3600" b="1">
                 <a:solidFill>
                   <a:srgbClr val="7C5CFC"/>
                 </a:solidFill>
               </a:defRPr>
             </a:pPr>
             <a:r>
-              <a:t>Project Requirements (8/8 Implemented)</a:t>
+              <a:t>Assignment Requirements Coverage</a:t>
             </a:r>
           </a:p>
         </p:txBody>
@@ -3749,8 +3654,8 @@
         </p:nvSpPr>
         <p:spPr>
           <a:xfrm>
-            <a:off x="457200" y="1051560"/>
-            <a:ext cx="8229600" cy="45720"/>
+            <a:off x="457200" y="960120"/>
+            <a:ext cx="8229600" cy="36576"/>
           </a:xfrm>
           <a:prstGeom prst="rect">
             <a:avLst/>
@@ -3794,8 +3699,8 @@
         </p:nvSpPr>
         <p:spPr>
           <a:xfrm>
-            <a:off x="731520" y="1371600"/>
-            <a:ext cx="7680960" cy="3474720"/>
+            <a:off x="731520" y="1234440"/>
+            <a:ext cx="7680960" cy="182880"/>
           </a:xfrm>
           <a:prstGeom prst="rect">
             <a:avLst/>
@@ -3803,17 +3708,52 @@
           <a:noFill/>
         </p:spPr>
         <p:txBody>
-          <a:bodyPr wrap="square">
+          <a:bodyPr wrap="none">
             <a:spAutoFit/>
           </a:bodyPr>
           <a:lstStyle/>
           <a:p>
             <a:pPr>
+              <a:defRPr sz="1300" b="1">
+                <a:solidFill>
+                  <a:srgbClr val="4CAF50"/>
+                </a:solidFill>
+              </a:defRPr>
+            </a:pPr>
+            <a:r>
+              <a:t>✓ Implemented &amp; Unit-Tested</a:t>
+            </a:r>
+          </a:p>
+        </p:txBody>
+      </p:sp>
+      <p:sp>
+        <p:nvSpPr>
+          <p:cNvPr id="5" name="TextBox 4"/>
+          <p:cNvSpPr txBox="1"/>
+          <p:nvPr/>
+        </p:nvSpPr>
+        <p:spPr>
+          <a:xfrm>
+            <a:off x="914400" y="1508760"/>
+            <a:ext cx="7498079" cy="1463040"/>
+          </a:xfrm>
+          <a:prstGeom prst="rect">
+            <a:avLst/>
+          </a:prstGeom>
+          <a:noFill/>
+        </p:spPr>
+        <p:txBody>
+          <a:bodyPr wrap="square" anchor="t">
+            <a:spAutoFit/>
+          </a:bodyPr>
+          <a:lstStyle/>
+          <a:p>
+            <a:pPr>
               <a:spcBef>
-                <a:spcPts val="400"/>
+                <a:spcPts val="300"/>
               </a:spcBef>
               <a:spcAft>
-                <a:spcPts val="400"/>
+                <a:spcPts val="300"/>
               </a:spcAft>
               <a:defRPr sz="1200">
                 <a:solidFill>
@@ -3822,16 +3762,16 @@
               </a:defRPr>
             </a:pPr>
             <a:r>
-              <a:t>✓ Admin GUI — Manage candidates, configure election, upload voter registry</a:t>
+              <a:t>• Admin GUI for candidate management</a:t>
             </a:r>
           </a:p>
           <a:p>
             <a:pPr>
               <a:spcBef>
-                <a:spcPts val="400"/>
+                <a:spcPts val="300"/>
               </a:spcBef>
               <a:spcAft>
-                <a:spcPts val="400"/>
+                <a:spcPts val="300"/>
               </a:spcAft>
               <a:defRPr sz="1200">
                 <a:solidFill>
@@ -3840,16 +3780,16 @@
               </a:defRPr>
             </a:pPr>
             <a:r>
-              <a:t>✓ Candidates — Add with name and 3 policy position scores (1–5 scale)</a:t>
+              <a:t>• Candidate add/store/retrieve</a:t>
             </a:r>
           </a:p>
           <a:p>
             <a:pPr>
               <a:spcBef>
-                <a:spcPts val="400"/>
+                <a:spcPts val="300"/>
               </a:spcBef>
               <a:spcAft>
-                <a:spcPts val="400"/>
+                <a:spcPts val="300"/>
               </a:spcAft>
               <a:defRPr sz="1200">
                 <a:solidFill>
@@ -3858,16 +3798,16 @@
               </a:defRPr>
             </a:pPr>
             <a:r>
-              <a:t>✓ Merkle voter registry — Voter eligibility verified via Merkle proof on-chain</a:t>
+              <a:t>• Merkle voter registry (proof verification)</a:t>
             </a:r>
           </a:p>
           <a:p>
             <a:pPr>
               <a:spcBef>
-                <a:spcPts val="400"/>
+                <a:spcPts val="300"/>
               </a:spcBef>
               <a:spcAft>
-                <a:spcPts val="400"/>
+                <a:spcPts val="300"/>
               </a:spcAft>
               <a:defRPr sz="1200">
                 <a:solidFill>
@@ -3876,16 +3816,16 @@
               </a:defRPr>
             </a:pPr>
             <a:r>
-              <a:t>✓ IPFS storage — Voter CSV uploaded to IPFS; CID stored in smart contract</a:t>
+              <a:t>• Direct voting with candidate selection</a:t>
             </a:r>
           </a:p>
           <a:p>
             <a:pPr>
               <a:spcBef>
-                <a:spcPts val="400"/>
+                <a:spcPts val="300"/>
               </a:spcBef>
               <a:spcAft>
-                <a:spcPts val="400"/>
+                <a:spcPts val="300"/>
               </a:spcAft>
               <a:defRPr sz="1200">
                 <a:solidFill>
@@ -3894,16 +3834,16 @@
               </a:defRPr>
             </a:pPr>
             <a:r>
-              <a:t>✓ Election time window — Admin sets start/end times; voting strictly enforced</a:t>
+              <a:t>• Election time window (start/end enforcement)</a:t>
             </a:r>
           </a:p>
           <a:p>
             <a:pPr>
               <a:spcBef>
-                <a:spcPts val="400"/>
+                <a:spcPts val="300"/>
               </a:spcBef>
               <a:spcAft>
-                <a:spcPts val="400"/>
+                <a:spcPts val="300"/>
               </a:spcAft>
               <a:defRPr sz="1200">
                 <a:solidFill>
@@ -3912,16 +3852,74 @@
               </a:defRPr>
             </a:pPr>
             <a:r>
-              <a:t>✓ Direct voting — Select candidate from dropdown; vote with Merkle proof</a:t>
-            </a:r>
-          </a:p>
+              <a:t>• Access control (admin-only functions)</a:t>
+            </a:r>
+          </a:p>
+        </p:txBody>
+      </p:sp>
+      <p:sp>
+        <p:nvSpPr>
+          <p:cNvPr id="6" name="TextBox 5"/>
+          <p:cNvSpPr txBox="1"/>
+          <p:nvPr/>
+        </p:nvSpPr>
+        <p:spPr>
+          <a:xfrm>
+            <a:off x="731520" y="3108960"/>
+            <a:ext cx="7680960" cy="182880"/>
+          </a:xfrm>
+          <a:prstGeom prst="rect">
+            <a:avLst/>
+          </a:prstGeom>
+          <a:noFill/>
+        </p:spPr>
+        <p:txBody>
+          <a:bodyPr wrap="none">
+            <a:spAutoFit/>
+          </a:bodyPr>
+          <a:lstStyle/>
+          <a:p>
+            <a:pPr>
+              <a:defRPr sz="1300" b="1">
+                <a:solidFill>
+                  <a:srgbClr val="F87171"/>
+                </a:solidFill>
+              </a:defRPr>
+            </a:pPr>
+            <a:r>
+              <a:t>⏳ Implemented but Pending Manual E2E Verification</a:t>
+            </a:r>
+          </a:p>
+        </p:txBody>
+      </p:sp>
+      <p:sp>
+        <p:nvSpPr>
+          <p:cNvPr id="7" name="TextBox 6"/>
+          <p:cNvSpPr txBox="1"/>
+          <p:nvPr/>
+        </p:nvSpPr>
+        <p:spPr>
+          <a:xfrm>
+            <a:off x="914400" y="3383280"/>
+            <a:ext cx="7498079" cy="1645920"/>
+          </a:xfrm>
+          <a:prstGeom prst="rect">
+            <a:avLst/>
+          </a:prstGeom>
+          <a:noFill/>
+        </p:spPr>
+        <p:txBody>
+          <a:bodyPr wrap="square" anchor="t">
+            <a:spAutoFit/>
+          </a:bodyPr>
+          <a:lstStyle/>
           <a:p>
             <a:pPr>
               <a:spcBef>
-                <a:spcPts val="400"/>
+                <a:spcPts val="300"/>
               </a:spcBef>
               <a:spcAft>
-                <a:spcPts val="400"/>
+                <a:spcPts val="300"/>
               </a:spcAft>
               <a:defRPr sz="1200">
                 <a:solidFill>
@@ -3930,16 +3928,16 @@
               </a:defRPr>
             </a:pPr>
             <a:r>
-              <a:t>✓ Questionnaire voting — 3-slider matching (Manhattan distance) auto-selects candidate</a:t>
+              <a:t>• IPFS voter registry upload and CID storage</a:t>
             </a:r>
           </a:p>
           <a:p>
             <a:pPr>
               <a:spcBef>
-                <a:spcPts val="400"/>
+                <a:spcPts val="300"/>
               </a:spcBef>
               <a:spcAft>
-                <a:spcPts val="400"/>
+                <a:spcPts val="300"/>
               </a:spcAft>
               <a:defRPr sz="1200">
                 <a:solidFill>
@@ -3948,16 +3946,16 @@
               </a:defRPr>
             </a:pPr>
             <a:r>
-              <a:t>✓ ERC-20 reward — 10 BAL tokens minted automatically per vote</a:t>
+              <a:t>• ERC-20 BAL reward distribution (10 BAL per vote)</a:t>
             </a:r>
           </a:p>
           <a:p>
             <a:pPr>
               <a:spcBef>
-                <a:spcPts val="400"/>
+                <a:spcPts val="300"/>
               </a:spcBef>
               <a:spcAft>
-                <a:spcPts val="400"/>
+                <a:spcPts val="300"/>
               </a:spcAft>
               <a:defRPr sz="1200">
                 <a:solidFill>
@@ -3966,7 +3964,25 @@
               </a:defRPr>
             </a:pPr>
             <a:r>
-              <a:t>✓ Sorted results — Candidates ranked by vote count; winner identified</a:t>
+              <a:t>• Questionnaire voting with Manhattan distance matching</a:t>
+            </a:r>
+          </a:p>
+          <a:p>
+            <a:pPr>
+              <a:spcBef>
+                <a:spcPts val="300"/>
+              </a:spcBef>
+              <a:spcAft>
+                <a:spcPts val="300"/>
+              </a:spcAft>
+              <a:defRPr sz="1200">
+                <a:solidFill>
+                  <a:srgbClr val="C9D1D9"/>
+                </a:solidFill>
+              </a:defRPr>
+            </a:pPr>
+            <a:r>
+              <a:t>• Post-election results display and winner identification</a:t>
             </a:r>
           </a:p>
         </p:txBody>
@@ -4468,7 +4484,7 @@
         <p:spPr>
           <a:xfrm>
             <a:off x="457200" y="274320"/>
-            <a:ext cx="8229600" cy="731520"/>
+            <a:ext cx="8229600" cy="548640"/>
           </a:xfrm>
           <a:prstGeom prst="rect">
             <a:avLst/>
@@ -4476,13 +4492,13 @@
           <a:noFill/>
         </p:spPr>
         <p:txBody>
-          <a:bodyPr wrap="none">
+          <a:bodyPr wrap="square">
             <a:spAutoFit/>
           </a:bodyPr>
           <a:lstStyle/>
           <a:p>
             <a:pPr>
-              <a:defRPr sz="3800" b="1">
+              <a:defRPr sz="3600" b="1">
                 <a:solidFill>
                   <a:srgbClr val="7C5CFC"/>
                 </a:solidFill>
@@ -4502,8 +4518,8 @@
         </p:nvSpPr>
         <p:spPr>
           <a:xfrm>
-            <a:off x="457200" y="1051560"/>
-            <a:ext cx="8229600" cy="45720"/>
+            <a:off x="457200" y="960120"/>
+            <a:ext cx="8229600" cy="36576"/>
           </a:xfrm>
           <a:prstGeom prst="rect">
             <a:avLst/>
@@ -4547,8 +4563,8 @@
         </p:nvSpPr>
         <p:spPr>
           <a:xfrm>
-            <a:off x="731520" y="1371600"/>
-            <a:ext cx="3840480" cy="3474720"/>
+            <a:off x="640080" y="1325880"/>
+            <a:ext cx="3931920" cy="2560320"/>
           </a:xfrm>
           <a:prstGeom prst="roundRect">
             <a:avLst/>
@@ -4592,8 +4608,8 @@
         </p:nvSpPr>
         <p:spPr>
           <a:xfrm>
-            <a:off x="914400" y="1508760"/>
-            <a:ext cx="3474720" cy="274320"/>
+            <a:off x="822960" y="1463040"/>
+            <a:ext cx="3566160" cy="228600"/>
           </a:xfrm>
           <a:prstGeom prst="rect">
             <a:avLst/>
@@ -4607,7 +4623,7 @@
           <a:lstStyle/>
           <a:p>
             <a:pPr>
-              <a:defRPr sz="1400" b="1">
+              <a:defRPr sz="1300" b="1">
                 <a:solidFill>
                   <a:srgbClr val="7C5CFC"/>
                 </a:solidFill>
@@ -4627,8 +4643,8 @@
         </p:nvSpPr>
         <p:spPr>
           <a:xfrm>
-            <a:off x="914400" y="1920240"/>
-            <a:ext cx="3474720" cy="2651760"/>
+            <a:off x="822960" y="1783080"/>
+            <a:ext cx="3566160" cy="1828800"/>
           </a:xfrm>
           <a:prstGeom prst="rect">
             <a:avLst/>
@@ -4636,17 +4652,17 @@
           <a:noFill/>
         </p:spPr>
         <p:txBody>
-          <a:bodyPr wrap="square">
+          <a:bodyPr wrap="square" anchor="t">
             <a:spAutoFit/>
           </a:bodyPr>
           <a:lstStyle/>
           <a:p>
             <a:pPr>
               <a:spcBef>
-                <a:spcPts val="400"/>
+                <a:spcPts val="300"/>
               </a:spcBef>
               <a:spcAft>
-                <a:spcPts val="400"/>
+                <a:spcPts val="300"/>
               </a:spcAft>
               <a:defRPr sz="1100">
                 <a:solidFill>
@@ -4661,10 +4677,10 @@
           <a:p>
             <a:pPr>
               <a:spcBef>
-                <a:spcPts val="400"/>
+                <a:spcPts val="300"/>
               </a:spcBef>
               <a:spcAft>
-                <a:spcPts val="400"/>
+                <a:spcPts val="300"/>
               </a:spcAft>
               <a:defRPr sz="1100">
                 <a:solidFill>
@@ -4679,10 +4695,10 @@
           <a:p>
             <a:pPr>
               <a:spcBef>
-                <a:spcPts val="400"/>
+                <a:spcPts val="300"/>
               </a:spcBef>
               <a:spcAft>
-                <a:spcPts val="400"/>
+                <a:spcPts val="300"/>
               </a:spcAft>
               <a:defRPr sz="1100">
                 <a:solidFill>
@@ -4697,10 +4713,10 @@
           <a:p>
             <a:pPr>
               <a:spcBef>
-                <a:spcPts val="400"/>
+                <a:spcPts val="300"/>
               </a:spcBef>
               <a:spcAft>
-                <a:spcPts val="400"/>
+                <a:spcPts val="300"/>
               </a:spcAft>
               <a:defRPr sz="1100">
                 <a:solidFill>
@@ -4715,10 +4731,10 @@
           <a:p>
             <a:pPr>
               <a:spcBef>
-                <a:spcPts val="400"/>
+                <a:spcPts val="300"/>
               </a:spcBef>
               <a:spcAft>
-                <a:spcPts val="400"/>
+                <a:spcPts val="300"/>
               </a:spcAft>
               <a:defRPr sz="1100">
                 <a:solidFill>
@@ -4728,24 +4744,6 @@
             </a:pPr>
             <a:r>
               <a:t>• CEI pattern (safe)</a:t>
-            </a:r>
-          </a:p>
-          <a:p>
-            <a:pPr>
-              <a:spcBef>
-                <a:spcPts val="400"/>
-              </a:spcBef>
-              <a:spcAft>
-                <a:spcPts val="400"/>
-              </a:spcAft>
-              <a:defRPr sz="1100">
-                <a:solidFill>
-                  <a:srgbClr val="C9D1D9"/>
-                </a:solidFill>
-              </a:defRPr>
-            </a:pPr>
-            <a:r>
-              <a:t>• Custom error types</a:t>
             </a:r>
           </a:p>
         </p:txBody>
@@ -4758,8 +4756,8 @@
         </p:nvSpPr>
         <p:spPr>
           <a:xfrm>
-            <a:off x="4754880" y="1371600"/>
-            <a:ext cx="3840480" cy="3474720"/>
+            <a:off x="4754880" y="1325880"/>
+            <a:ext cx="3931920" cy="2560320"/>
           </a:xfrm>
           <a:prstGeom prst="roundRect">
             <a:avLst/>
@@ -4803,8 +4801,8 @@
         </p:nvSpPr>
         <p:spPr>
           <a:xfrm>
-            <a:off x="4937760" y="1508760"/>
-            <a:ext cx="3474720" cy="274320"/>
+            <a:off x="4937760" y="1463040"/>
+            <a:ext cx="3566160" cy="228600"/>
           </a:xfrm>
           <a:prstGeom prst="rect">
             <a:avLst/>
@@ -4818,7 +4816,7 @@
           <a:lstStyle/>
           <a:p>
             <a:pPr>
-              <a:defRPr sz="1400" b="1">
+              <a:defRPr sz="1300" b="1">
                 <a:solidFill>
                   <a:srgbClr val="7C5CFC"/>
                 </a:solidFill>
@@ -4838,8 +4836,8 @@
         </p:nvSpPr>
         <p:spPr>
           <a:xfrm>
-            <a:off x="4937760" y="1920240"/>
-            <a:ext cx="3474720" cy="2651760"/>
+            <a:off x="4937760" y="1783080"/>
+            <a:ext cx="3566160" cy="1828800"/>
           </a:xfrm>
           <a:prstGeom prst="rect">
             <a:avLst/>
@@ -4847,17 +4845,17 @@
           <a:noFill/>
         </p:spPr>
         <p:txBody>
-          <a:bodyPr wrap="square">
+          <a:bodyPr wrap="square" anchor="t">
             <a:spAutoFit/>
           </a:bodyPr>
           <a:lstStyle/>
           <a:p>
             <a:pPr>
               <a:spcBef>
-                <a:spcPts val="400"/>
+                <a:spcPts val="300"/>
               </a:spcBef>
               <a:spcAft>
-                <a:spcPts val="400"/>
+                <a:spcPts val="300"/>
               </a:spcAft>
               <a:defRPr sz="1100">
                 <a:solidFill>
@@ -4866,16 +4864,16 @@
               </a:defRPr>
             </a:pPr>
             <a:r>
-              <a:t>• Immutable minter address</a:t>
+              <a:t>• Minter fixed at deployment</a:t>
             </a:r>
           </a:p>
           <a:p>
             <a:pPr>
               <a:spcBef>
-                <a:spcPts val="400"/>
+                <a:spcPts val="300"/>
               </a:spcBef>
               <a:spcAft>
-                <a:spcPts val="400"/>
+                <a:spcPts val="300"/>
               </a:spcAft>
               <a:defRPr sz="1100">
                 <a:solidFill>
@@ -4890,10 +4888,10 @@
           <a:p>
             <a:pPr>
               <a:spcBef>
-                <a:spcPts val="400"/>
+                <a:spcPts val="300"/>
               </a:spcBef>
               <a:spcAft>
-                <a:spcPts val="400"/>
+                <a:spcPts val="300"/>
               </a:spcAft>
               <a:defRPr sz="1100">
                 <a:solidFill>
@@ -4908,10 +4906,10 @@
           <a:p>
             <a:pPr>
               <a:spcBef>
-                <a:spcPts val="400"/>
+                <a:spcPts val="300"/>
               </a:spcBef>
               <a:spcAft>
-                <a:spcPts val="400"/>
+                <a:spcPts val="300"/>
               </a:spcAft>
               <a:defRPr sz="1100">
                 <a:solidFill>
@@ -4926,10 +4924,10 @@
           <a:p>
             <a:pPr>
               <a:spcBef>
-                <a:spcPts val="400"/>
+                <a:spcPts val="300"/>
               </a:spcBef>
               <a:spcAft>
-                <a:spcPts val="400"/>
+                <a:spcPts val="300"/>
               </a:spcAft>
               <a:defRPr sz="1100">
                 <a:solidFill>
@@ -4951,8 +4949,8 @@
         </p:nvSpPr>
         <p:spPr>
           <a:xfrm>
-            <a:off x="731520" y="4572000"/>
-            <a:ext cx="7680960" cy="457200"/>
+            <a:off x="640080" y="4023360"/>
+            <a:ext cx="7863840" cy="914400"/>
           </a:xfrm>
           <a:prstGeom prst="rect">
             <a:avLst/>
@@ -4973,7 +4971,7 @@
               </a:defRPr>
             </a:pPr>
             <a:r>
-              <a:t>✓ Test Coverage: 28/28 passing — Double-voting, Merkle validation, time windows, BAL minting, results</a:t>
+              <a:t>✓ Test Coverage: 28/28 passing — Double-voting, Merkle validation, time windows, BAL minting</a:t>
             </a:r>
           </a:p>
         </p:txBody>
@@ -5013,7 +5011,7 @@
         <p:spPr>
           <a:xfrm>
             <a:off x="457200" y="274320"/>
-            <a:ext cx="8229600" cy="731520"/>
+            <a:ext cx="8229600" cy="548640"/>
           </a:xfrm>
           <a:prstGeom prst="rect">
             <a:avLst/>
@@ -5021,13 +5019,13 @@
           <a:noFill/>
         </p:spPr>
         <p:txBody>
-          <a:bodyPr wrap="none">
+          <a:bodyPr wrap="square">
             <a:spAutoFit/>
           </a:bodyPr>
           <a:lstStyle/>
           <a:p>
             <a:pPr>
-              <a:defRPr sz="3800" b="1">
+              <a:defRPr sz="3600" b="1">
                 <a:solidFill>
                   <a:srgbClr val="7C5CFC"/>
                 </a:solidFill>
@@ -5047,8 +5045,8 @@
         </p:nvSpPr>
         <p:spPr>
           <a:xfrm>
-            <a:off x="457200" y="1051560"/>
-            <a:ext cx="8229600" cy="45720"/>
+            <a:off x="457200" y="960120"/>
+            <a:ext cx="8229600" cy="36576"/>
           </a:xfrm>
           <a:prstGeom prst="rect">
             <a:avLst/>
@@ -5092,8 +5090,8 @@
         </p:nvSpPr>
         <p:spPr>
           <a:xfrm>
-            <a:off x="731520" y="1371600"/>
-            <a:ext cx="3840480" cy="274320"/>
+            <a:off x="731520" y="1234440"/>
+            <a:ext cx="3840480" cy="182880"/>
           </a:xfrm>
           <a:prstGeom prst="rect">
             <a:avLst/>
@@ -5107,7 +5105,7 @@
           <a:lstStyle/>
           <a:p>
             <a:pPr>
-              <a:defRPr sz="1300" b="1">
+              <a:defRPr sz="1200" b="1">
                 <a:solidFill>
                   <a:srgbClr val="7C5CFC"/>
                 </a:solidFill>
@@ -5127,8 +5125,8 @@
         </p:nvSpPr>
         <p:spPr>
           <a:xfrm>
-            <a:off x="914400" y="1783080"/>
-            <a:ext cx="3657600" cy="2560320"/>
+            <a:off x="914400" y="1508760"/>
+            <a:ext cx="3657600" cy="1920240"/>
           </a:xfrm>
           <a:prstGeom prst="rect">
             <a:avLst/>
@@ -5136,17 +5134,17 @@
           <a:noFill/>
         </p:spPr>
         <p:txBody>
-          <a:bodyPr wrap="square">
+          <a:bodyPr wrap="square" anchor="t">
             <a:spAutoFit/>
           </a:bodyPr>
           <a:lstStyle/>
           <a:p>
             <a:pPr>
               <a:spcBef>
-                <a:spcPts val="400"/>
+                <a:spcPts val="300"/>
               </a:spcBef>
               <a:spcAft>
-                <a:spcPts val="400"/>
+                <a:spcPts val="300"/>
               </a:spcAft>
               <a:defRPr sz="1100">
                 <a:solidFill>
@@ -5161,10 +5159,10 @@
           <a:p>
             <a:pPr>
               <a:spcBef>
-                <a:spcPts val="400"/>
+                <a:spcPts val="300"/>
               </a:spcBef>
               <a:spcAft>
-                <a:spcPts val="400"/>
+                <a:spcPts val="300"/>
               </a:spcAft>
               <a:defRPr sz="1100">
                 <a:solidFill>
@@ -5179,10 +5177,10 @@
           <a:p>
             <a:pPr>
               <a:spcBef>
-                <a:spcPts val="400"/>
+                <a:spcPts val="300"/>
               </a:spcBef>
               <a:spcAft>
-                <a:spcPts val="400"/>
+                <a:spcPts val="300"/>
               </a:spcAft>
               <a:defRPr sz="1100">
                 <a:solidFill>
@@ -5197,10 +5195,10 @@
           <a:p>
             <a:pPr>
               <a:spcBef>
-                <a:spcPts val="400"/>
+                <a:spcPts val="300"/>
               </a:spcBef>
               <a:spcAft>
-                <a:spcPts val="400"/>
+                <a:spcPts val="300"/>
               </a:spcAft>
               <a:defRPr sz="1100">
                 <a:solidFill>
@@ -5215,10 +5213,10 @@
           <a:p>
             <a:pPr>
               <a:spcBef>
-                <a:spcPts val="400"/>
+                <a:spcPts val="300"/>
               </a:spcBef>
               <a:spcAft>
-                <a:spcPts val="400"/>
+                <a:spcPts val="300"/>
               </a:spcAft>
               <a:defRPr sz="1100">
                 <a:solidFill>
@@ -5233,10 +5231,10 @@
           <a:p>
             <a:pPr>
               <a:spcBef>
-                <a:spcPts val="400"/>
+                <a:spcPts val="300"/>
               </a:spcBef>
               <a:spcAft>
-                <a:spcPts val="400"/>
+                <a:spcPts val="300"/>
               </a:spcAft>
               <a:defRPr sz="1100">
                 <a:solidFill>
@@ -5251,10 +5249,10 @@
           <a:p>
             <a:pPr>
               <a:spcBef>
-                <a:spcPts val="400"/>
+                <a:spcPts val="300"/>
               </a:spcBef>
               <a:spcAft>
-                <a:spcPts val="400"/>
+                <a:spcPts val="300"/>
               </a:spcAft>
               <a:defRPr sz="1100">
                 <a:solidFill>
@@ -5276,8 +5274,8 @@
         </p:nvSpPr>
         <p:spPr>
           <a:xfrm>
-            <a:off x="4754880" y="1371600"/>
-            <a:ext cx="3840480" cy="274320"/>
+            <a:off x="4754880" y="1234440"/>
+            <a:ext cx="3840480" cy="182880"/>
           </a:xfrm>
           <a:prstGeom prst="rect">
             <a:avLst/>
@@ -5291,7 +5289,7 @@
           <a:lstStyle/>
           <a:p>
             <a:pPr>
-              <a:defRPr sz="1300" b="1">
+              <a:defRPr sz="1200" b="1">
                 <a:solidFill>
                   <a:srgbClr val="7C5CFC"/>
                 </a:solidFill>
@@ -5311,8 +5309,8 @@
         </p:nvSpPr>
         <p:spPr>
           <a:xfrm>
-            <a:off x="4937760" y="1783080"/>
-            <a:ext cx="3657600" cy="2560320"/>
+            <a:off x="4937760" y="1508760"/>
+            <a:ext cx="3657600" cy="1920240"/>
           </a:xfrm>
           <a:prstGeom prst="rect">
             <a:avLst/>
@@ -5320,17 +5318,17 @@
           <a:noFill/>
         </p:spPr>
         <p:txBody>
-          <a:bodyPr wrap="square">
+          <a:bodyPr wrap="square" anchor="t">
             <a:spAutoFit/>
           </a:bodyPr>
           <a:lstStyle/>
           <a:p>
             <a:pPr>
               <a:spcBef>
-                <a:spcPts val="400"/>
+                <a:spcPts val="300"/>
               </a:spcBef>
               <a:spcAft>
-                <a:spcPts val="400"/>
+                <a:spcPts val="300"/>
               </a:spcAft>
               <a:defRPr sz="1100">
                 <a:solidFill>
@@ -5345,10 +5343,10 @@
           <a:p>
             <a:pPr>
               <a:spcBef>
-                <a:spcPts val="400"/>
+                <a:spcPts val="300"/>
               </a:spcBef>
               <a:spcAft>
-                <a:spcPts val="400"/>
+                <a:spcPts val="300"/>
               </a:spcAft>
               <a:defRPr sz="1100">
                 <a:solidFill>
@@ -5357,16 +5355,16 @@
               </a:defRPr>
             </a:pPr>
             <a:r>
-              <a:t>   (1–5 scale per topic)</a:t>
+              <a:t>2. System calculates distance</a:t>
             </a:r>
           </a:p>
           <a:p>
             <a:pPr>
               <a:spcBef>
-                <a:spcPts val="400"/>
+                <a:spcPts val="300"/>
               </a:spcBef>
               <a:spcAft>
-                <a:spcPts val="400"/>
+                <a:spcPts val="300"/>
               </a:spcAft>
               <a:defRPr sz="1100">
                 <a:solidFill>
@@ -5375,16 +5373,16 @@
               </a:defRPr>
             </a:pPr>
             <a:r>
-              <a:t>2. System calculates distance</a:t>
+              <a:t>3. Closest candidate selected</a:t>
             </a:r>
           </a:p>
           <a:p>
             <a:pPr>
               <a:spcBef>
-                <a:spcPts val="400"/>
+                <a:spcPts val="300"/>
               </a:spcBef>
               <a:spcAft>
-                <a:spcPts val="400"/>
+                <a:spcPts val="300"/>
               </a:spcAft>
               <a:defRPr sz="1100">
                 <a:solidFill>
@@ -5393,16 +5391,16 @@
               </a:defRPr>
             </a:pPr>
             <a:r>
-              <a:t>   to all candidates</a:t>
+              <a:t>4. Vote submitted (with proof)</a:t>
             </a:r>
           </a:p>
           <a:p>
             <a:pPr>
               <a:spcBef>
-                <a:spcPts val="400"/>
+                <a:spcPts val="300"/>
               </a:spcBef>
               <a:spcAft>
-                <a:spcPts val="400"/>
+                <a:spcPts val="300"/>
               </a:spcAft>
               <a:defRPr sz="1100">
                 <a:solidFill>
@@ -5411,43 +5409,7 @@
               </a:defRPr>
             </a:pPr>
             <a:r>
-              <a:t>3. Closest candidate selected</a:t>
-            </a:r>
-          </a:p>
-          <a:p>
-            <a:pPr>
-              <a:spcBef>
-                <a:spcPts val="400"/>
-              </a:spcBef>
-              <a:spcAft>
-                <a:spcPts val="400"/>
-              </a:spcAft>
-              <a:defRPr sz="1100">
-                <a:solidFill>
-                  <a:srgbClr val="C9D1D9"/>
-                </a:solidFill>
-              </a:defRPr>
-            </a:pPr>
-            <a:r>
-              <a:t>4. Vote submitted (with proof)</a:t>
-            </a:r>
-          </a:p>
-          <a:p>
-            <a:pPr>
-              <a:spcBef>
-                <a:spcPts val="400"/>
-              </a:spcBef>
-              <a:spcAft>
-                <a:spcPts val="400"/>
-              </a:spcAft>
-              <a:defRPr sz="1100">
-                <a:solidFill>
-                  <a:srgbClr val="C9D1D9"/>
-                </a:solidFill>
-              </a:defRPr>
-            </a:pPr>
-            <a:r>
-              <a:t>5. Candidate revealed after vote</a:t>
+              <a:t>5. UI reveals matched candidate after submission</a:t>
             </a:r>
           </a:p>
         </p:txBody>
@@ -5460,8 +5422,8 @@
         </p:nvSpPr>
         <p:spPr>
           <a:xfrm>
-            <a:off x="731520" y="4526280"/>
-            <a:ext cx="7680960" cy="457200"/>
+            <a:off x="731520" y="3611880"/>
+            <a:ext cx="7680960" cy="1280160"/>
           </a:xfrm>
           <a:prstGeom prst="rect">
             <a:avLst/>
@@ -5482,7 +5444,7 @@
               </a:defRPr>
             </a:pPr>
             <a:r>
-              <a:t>⚠️ Anonymity Limitation: Questionnaire result is UI-hidden pre-vote but visible on-chain in transaction calldata (not cryptographically private).</a:t>
+              <a:t>⚠️ Anonymity Limitation: Questionnaire result is hidden in UI before vote submission, but the matched candidate ID is visible in blockchain transaction calldata. This is not cryptographically private.</a:t>
             </a:r>
           </a:p>
         </p:txBody>
@@ -5522,7 +5484,7 @@
         <p:spPr>
           <a:xfrm>
             <a:off x="457200" y="274320"/>
-            <a:ext cx="8229600" cy="731520"/>
+            <a:ext cx="8229600" cy="548640"/>
           </a:xfrm>
           <a:prstGeom prst="rect">
             <a:avLst/>
@@ -5530,13 +5492,13 @@
           <a:noFill/>
         </p:spPr>
         <p:txBody>
-          <a:bodyPr wrap="none">
+          <a:bodyPr wrap="square">
             <a:spAutoFit/>
           </a:bodyPr>
           <a:lstStyle/>
           <a:p>
             <a:pPr>
-              <a:defRPr sz="3800" b="1">
+              <a:defRPr sz="3600" b="1">
                 <a:solidFill>
                   <a:srgbClr val="7C5CFC"/>
                 </a:solidFill>
@@ -5556,8 +5518,8 @@
         </p:nvSpPr>
         <p:spPr>
           <a:xfrm>
-            <a:off x="457200" y="1051560"/>
-            <a:ext cx="8229600" cy="45720"/>
+            <a:off x="457200" y="960120"/>
+            <a:ext cx="8229600" cy="36576"/>
           </a:xfrm>
           <a:prstGeom prst="rect">
             <a:avLst/>
@@ -5601,8 +5563,8 @@
         </p:nvSpPr>
         <p:spPr>
           <a:xfrm>
-            <a:off x="914400" y="1371600"/>
-            <a:ext cx="7315200" cy="3474720"/>
+            <a:off x="914400" y="1234440"/>
+            <a:ext cx="7315200" cy="2560320"/>
           </a:xfrm>
           <a:prstGeom prst="rect">
             <a:avLst/>
@@ -5610,17 +5572,17 @@
           <a:noFill/>
         </p:spPr>
         <p:txBody>
-          <a:bodyPr wrap="square">
+          <a:bodyPr wrap="square" anchor="t">
             <a:spAutoFit/>
           </a:bodyPr>
           <a:lstStyle/>
           <a:p>
             <a:pPr>
               <a:spcBef>
-                <a:spcPts val="400"/>
+                <a:spcPts val="300"/>
               </a:spcBef>
               <a:spcAft>
-                <a:spcPts val="400"/>
+                <a:spcPts val="300"/>
               </a:spcAft>
               <a:defRPr sz="1200">
                 <a:solidFill>
@@ -5635,10 +5597,10 @@
           <a:p>
             <a:pPr>
               <a:spcBef>
-                <a:spcPts val="400"/>
+                <a:spcPts val="300"/>
               </a:spcBef>
               <a:spcAft>
-                <a:spcPts val="400"/>
+                <a:spcPts val="300"/>
               </a:spcAft>
               <a:defRPr sz="1200">
                 <a:solidFill>
@@ -5653,10 +5615,10 @@
           <a:p>
             <a:pPr>
               <a:spcBef>
-                <a:spcPts val="400"/>
+                <a:spcPts val="300"/>
               </a:spcBef>
               <a:spcAft>
-                <a:spcPts val="400"/>
+                <a:spcPts val="300"/>
               </a:spcAft>
               <a:defRPr sz="1200">
                 <a:solidFill>
@@ -5671,10 +5633,10 @@
           <a:p>
             <a:pPr>
               <a:spcBef>
-                <a:spcPts val="400"/>
+                <a:spcPts val="300"/>
               </a:spcBef>
               <a:spcAft>
-                <a:spcPts val="400"/>
+                <a:spcPts val="300"/>
               </a:spcAft>
               <a:defRPr sz="1200">
                 <a:solidFill>
@@ -5689,10 +5651,10 @@
           <a:p>
             <a:pPr>
               <a:spcBef>
-                <a:spcPts val="400"/>
+                <a:spcPts val="300"/>
               </a:spcBef>
               <a:spcAft>
-                <a:spcPts val="400"/>
+                <a:spcPts val="300"/>
               </a:spcAft>
               <a:defRPr sz="1200">
                 <a:solidFill>
@@ -5707,10 +5669,10 @@
           <a:p>
             <a:pPr>
               <a:spcBef>
-                <a:spcPts val="400"/>
+                <a:spcPts val="300"/>
               </a:spcBef>
               <a:spcAft>
-                <a:spcPts val="400"/>
+                <a:spcPts val="300"/>
               </a:spcAft>
               <a:defRPr sz="1200">
                 <a:solidFill>
@@ -5725,10 +5687,10 @@
           <a:p>
             <a:pPr>
               <a:spcBef>
-                <a:spcPts val="400"/>
+                <a:spcPts val="300"/>
               </a:spcBef>
               <a:spcAft>
-                <a:spcPts val="400"/>
+                <a:spcPts val="300"/>
               </a:spcAft>
               <a:defRPr sz="1200">
                 <a:solidFill>
@@ -5743,10 +5705,10 @@
           <a:p>
             <a:pPr>
               <a:spcBef>
-                <a:spcPts val="400"/>
+                <a:spcPts val="300"/>
               </a:spcBef>
               <a:spcAft>
-                <a:spcPts val="400"/>
+                <a:spcPts val="300"/>
               </a:spcAft>
               <a:defRPr sz="1200">
                 <a:solidFill>
@@ -5761,10 +5723,10 @@
           <a:p>
             <a:pPr>
               <a:spcBef>
-                <a:spcPts val="400"/>
+                <a:spcPts val="300"/>
               </a:spcBef>
               <a:spcAft>
-                <a:spcPts val="400"/>
+                <a:spcPts val="300"/>
               </a:spcAft>
               <a:defRPr sz="1200">
                 <a:solidFill>
@@ -5779,10 +5741,10 @@
           <a:p>
             <a:pPr>
               <a:spcBef>
-                <a:spcPts val="400"/>
+                <a:spcPts val="300"/>
               </a:spcBef>
               <a:spcAft>
-                <a:spcPts val="400"/>
+                <a:spcPts val="300"/>
               </a:spcAft>
               <a:defRPr sz="1200">
                 <a:solidFill>
@@ -5791,7 +5753,7 @@
               </a:defRPr>
             </a:pPr>
             <a:r>
-              <a:t>10. Results displayed: winner + bar chart + ranked table</a:t>
+              <a:t>10. Results displayed: winner + ranked table</a:t>
             </a:r>
           </a:p>
         </p:txBody>
@@ -5804,8 +5766,8 @@
         </p:nvSpPr>
         <p:spPr>
           <a:xfrm>
-            <a:off x="731520" y="4572000"/>
-            <a:ext cx="7680960" cy="457200"/>
+            <a:off x="731520" y="3931920"/>
+            <a:ext cx="7680960" cy="1051560"/>
           </a:xfrm>
           <a:prstGeom prst="rect">
             <a:avLst/>
@@ -5826,7 +5788,7 @@
               </a:defRPr>
             </a:pPr>
             <a:r>
-              <a:t>Verification Status: All 10 steps executable. E2E manual test flow documented in COMPLIANCE_AUDIT.md. Pending: full user execution test.</a:t>
+              <a:t>Implementation complete; full manual E2E verification pending. Space reserved for screenshots after manual testing.</a:t>
             </a:r>
           </a:p>
         </p:txBody>
@@ -5866,7 +5828,7 @@
         <p:spPr>
           <a:xfrm>
             <a:off x="457200" y="274320"/>
-            <a:ext cx="8229600" cy="731520"/>
+            <a:ext cx="8229600" cy="548640"/>
           </a:xfrm>
           <a:prstGeom prst="rect">
             <a:avLst/>
@@ -5874,13 +5836,13 @@
           <a:noFill/>
         </p:spPr>
         <p:txBody>
-          <a:bodyPr wrap="none">
+          <a:bodyPr wrap="square">
             <a:spAutoFit/>
           </a:bodyPr>
           <a:lstStyle/>
           <a:p>
             <a:pPr>
-              <a:defRPr sz="3800" b="1">
+              <a:defRPr sz="3600" b="1">
                 <a:solidFill>
                   <a:srgbClr val="7C5CFC"/>
                 </a:solidFill>
@@ -5900,8 +5862,8 @@
         </p:nvSpPr>
         <p:spPr>
           <a:xfrm>
-            <a:off x="457200" y="1051560"/>
-            <a:ext cx="8229600" cy="45720"/>
+            <a:off x="457200" y="960120"/>
+            <a:ext cx="8229600" cy="36576"/>
           </a:xfrm>
           <a:prstGeom prst="rect">
             <a:avLst/>
@@ -5945,8 +5907,8 @@
         </p:nvSpPr>
         <p:spPr>
           <a:xfrm>
-            <a:off x="731520" y="1371600"/>
-            <a:ext cx="7680960" cy="274320"/>
+            <a:off x="731520" y="1234440"/>
+            <a:ext cx="7680960" cy="182880"/>
           </a:xfrm>
           <a:prstGeom prst="rect">
             <a:avLst/>
@@ -5960,14 +5922,14 @@
           <a:lstStyle/>
           <a:p>
             <a:pPr>
-              <a:defRPr sz="1300" b="1">
+              <a:defRPr sz="1200" b="1">
                 <a:solidFill>
                   <a:srgbClr val="79C0FF"/>
                 </a:solidFill>
               </a:defRPr>
             </a:pPr>
             <a:r>
-              <a:t>Sepolia Deployment (Verified)</a:t>
+              <a:t>Sepolia Deployment (Current)</a:t>
             </a:r>
           </a:p>
         </p:txBody>
@@ -5980,8 +5942,8 @@
         </p:nvSpPr>
         <p:spPr>
           <a:xfrm>
-            <a:off x="914400" y="1783080"/>
-            <a:ext cx="7680960" cy="777240"/>
+            <a:off x="914400" y="1554480"/>
+            <a:ext cx="7680960" cy="731520"/>
           </a:xfrm>
           <a:prstGeom prst="rect">
             <a:avLst/>
@@ -5989,17 +5951,17 @@
           <a:noFill/>
         </p:spPr>
         <p:txBody>
-          <a:bodyPr wrap="square">
+          <a:bodyPr wrap="square" anchor="t">
             <a:spAutoFit/>
           </a:bodyPr>
           <a:lstStyle/>
           <a:p>
             <a:pPr>
               <a:spcBef>
-                <a:spcPts val="400"/>
+                <a:spcPts val="300"/>
               </a:spcBef>
               <a:spcAft>
-                <a:spcPts val="400"/>
+                <a:spcPts val="300"/>
               </a:spcAft>
               <a:defRPr sz="1100">
                 <a:solidFill>
@@ -6008,16 +5970,16 @@
               </a:defRPr>
             </a:pPr>
             <a:r>
-              <a:t>Election: 0xeA97c7e23B1300ea9523A3630827C85336e2B12F</a:t>
+              <a:t>Election: 0x312a7Cc5e9D388d418238Fc6382E4001D79c6937</a:t>
             </a:r>
           </a:p>
           <a:p>
             <a:pPr>
               <a:spcBef>
-                <a:spcPts val="400"/>
+                <a:spcPts val="300"/>
               </a:spcBef>
               <a:spcAft>
-                <a:spcPts val="400"/>
+                <a:spcPts val="300"/>
               </a:spcAft>
               <a:defRPr sz="1100">
                 <a:solidFill>
@@ -6026,16 +5988,16 @@
               </a:defRPr>
             </a:pPr>
             <a:r>
-              <a:t>BALToken: 0xab8f347351720Ce0Fa8527b6826149da6dB950C9</a:t>
+              <a:t>BALToken: 0x7378be2e720b033bFAF6832Dc2276BedFdCe176f</a:t>
             </a:r>
           </a:p>
           <a:p>
             <a:pPr>
               <a:spcBef>
-                <a:spcPts val="400"/>
+                <a:spcPts val="300"/>
               </a:spcBef>
               <a:spcAft>
-                <a:spcPts val="400"/>
+                <a:spcPts val="300"/>
               </a:spcAft>
               <a:defRPr sz="1100">
                 <a:solidFill>
@@ -6057,8 +6019,8 @@
         </p:nvSpPr>
         <p:spPr>
           <a:xfrm>
-            <a:off x="731520" y="2743200"/>
-            <a:ext cx="7680960" cy="274320"/>
+            <a:off x="731520" y="2423160"/>
+            <a:ext cx="7680960" cy="182880"/>
           </a:xfrm>
           <a:prstGeom prst="rect">
             <a:avLst/>
@@ -6072,7 +6034,7 @@
           <a:lstStyle/>
           <a:p>
             <a:pPr>
-              <a:defRPr sz="1300" b="1">
+              <a:defRPr sz="1200" b="1">
                 <a:solidFill>
                   <a:srgbClr val="79C0FF"/>
                 </a:solidFill>
@@ -6092,8 +6054,8 @@
         </p:nvSpPr>
         <p:spPr>
           <a:xfrm>
-            <a:off x="914400" y="3108960"/>
-            <a:ext cx="7680960" cy="1554480"/>
+            <a:off x="914400" y="2697480"/>
+            <a:ext cx="7680960" cy="1188720"/>
           </a:xfrm>
           <a:prstGeom prst="rect">
             <a:avLst/>
@@ -6101,17 +6063,17 @@
           <a:noFill/>
         </p:spPr>
         <p:txBody>
-          <a:bodyPr wrap="square">
+          <a:bodyPr wrap="square" anchor="t">
             <a:spAutoFit/>
           </a:bodyPr>
           <a:lstStyle/>
           <a:p>
             <a:pPr>
               <a:spcBef>
-                <a:spcPts val="400"/>
+                <a:spcPts val="300"/>
               </a:spcBef>
               <a:spcAft>
-                <a:spcPts val="400"/>
+                <a:spcPts val="300"/>
               </a:spcAft>
               <a:defRPr sz="1100">
                 <a:solidFill>
@@ -6126,10 +6088,10 @@
           <a:p>
             <a:pPr>
               <a:spcBef>
-                <a:spcPts val="400"/>
+                <a:spcPts val="300"/>
               </a:spcBef>
               <a:spcAft>
-                <a:spcPts val="400"/>
+                <a:spcPts val="300"/>
               </a:spcAft>
               <a:defRPr sz="1100">
                 <a:solidFill>
@@ -6144,10 +6106,10 @@
           <a:p>
             <a:pPr>
               <a:spcBef>
-                <a:spcPts val="400"/>
+                <a:spcPts val="300"/>
               </a:spcBef>
               <a:spcAft>
-                <a:spcPts val="400"/>
+                <a:spcPts val="300"/>
               </a:spcAft>
               <a:defRPr sz="1100">
                 <a:solidFill>
@@ -6162,10 +6124,10 @@
           <a:p>
             <a:pPr>
               <a:spcBef>
-                <a:spcPts val="400"/>
+                <a:spcPts val="300"/>
               </a:spcBef>
               <a:spcAft>
-                <a:spcPts val="400"/>
+                <a:spcPts val="300"/>
               </a:spcAft>
               <a:defRPr sz="1100">
                 <a:solidFill>
@@ -6187,8 +6149,8 @@
         </p:nvSpPr>
         <p:spPr>
           <a:xfrm>
-            <a:off x="731520" y="4663440"/>
-            <a:ext cx="7680960" cy="365760"/>
+            <a:off x="731520" y="4023360"/>
+            <a:ext cx="7680960" cy="822960"/>
           </a:xfrm>
           <a:prstGeom prst="rect">
             <a:avLst/>
@@ -6196,13 +6158,13 @@
           <a:noFill/>
         </p:spPr>
         <p:txBody>
-          <a:bodyPr wrap="none">
+          <a:bodyPr wrap="square">
             <a:spAutoFit/>
           </a:bodyPr>
           <a:lstStyle/>
           <a:p>
             <a:pPr>
-              <a:defRPr sz="1200" b="1">
+              <a:defRPr sz="1100" b="1">
                 <a:solidFill>
                   <a:srgbClr val="79C0FF"/>
                 </a:solidFill>

</xml_diff>